<commit_message>
Add revenue-foregone table to report and slides
New table: annual fiscal cost (IDR T) + % of 2024 GDP + 20-year total
for each incentive type (tax holiday, super deduction, SEZ VAT).
Grand total: IDR 11.1T/yr (0.050% GDP), IDR 138.1T over incentive periods.

- reports/fiscal_report.tex: new section inserted before Pillar 2 split
- reports/fiscal_slides.tex: new slide 2 (revenue table); tier table → slide 3; assumptions → slide 4
- reports/make_slides.py: matching new PPTX slide added
- Rebuilt all PDFs and PPTX

https://claude.ai/code/session_018m2ceypEakZpmjRE2PTWZv
</commit_message>
<xml_diff>
--- a/reports/fiscal_slides.pptx
+++ b/reports/fiscal_slides.pptx
@@ -8,6 +8,7 @@
     <p:sldId id="256" r:id="rId7"/>
     <p:sldId id="257" r:id="rId8"/>
     <p:sldId id="258" r:id="rId9"/>
+    <p:sldId id="259" r:id="rId10"/>
   </p:sldIdLst>
   <p:sldSz cx="12188952" cy="6858000" type="screen4x3"/>
   <p:notesSz cx="6858000" cy="9144000"/>
@@ -4384,6 +4385,738 @@
                   <a:srgbClr val="FFFFFF"/>
                 </a:solidFill>
               </a:rPr>
+              <a:t>  Government Revenue Foregone — Annual Cost &amp; 20-Year Projection</a:t>
+            </a:r>
+          </a:p>
+        </p:txBody>
+      </p:sp>
+      <p:graphicFrame>
+        <p:nvGraphicFramePr>
+          <p:cNvPr id="3" name="Table 2"/>
+          <p:cNvGraphicFramePr>
+            <a:graphicFrameLocks noGrp="1"/>
+          </p:cNvGraphicFramePr>
+          <p:nvPr/>
+        </p:nvGraphicFramePr>
+        <p:xfrm>
+          <a:off x="365760" y="1005840"/>
+          <a:ext cx="11457432" cy="2560320"/>
+        </p:xfrm>
+        <a:graphic>
+          <a:graphicData uri="http://schemas.openxmlformats.org/drawingml/2006/table">
+            <a:tbl>
+              <a:tblPr firstRow="1" bandRow="1">
+                <a:tableStyleId>{5C22544A-7EE6-4342-B048-85BDC9FD1C3A}</a:tableStyleId>
+              </a:tblPr>
+              <a:tblGrid>
+                <a:gridCol w="3437229"/>
+                <a:gridCol w="1947763"/>
+                <a:gridCol w="1374891"/>
+                <a:gridCol w="2520635"/>
+                <a:gridCol w="2176914"/>
+              </a:tblGrid>
+              <a:tr h="512064">
+                <a:tc>
+                  <a:txBody>
+                    <a:bodyPr wrap="none"/>
+                    <a:lstStyle/>
+                    <a:p>
+                      <a:pPr algn="l"/>
+                      <a:r>
+                        <a:rPr sz="1000" b="1">
+                          <a:solidFill>
+                            <a:srgbClr val="FFFFFF"/>
+                          </a:solidFill>
+                        </a:rPr>
+                        <a:t>Incentive</a:t>
+                      </a:r>
+                    </a:p>
+                  </a:txBody>
+                  <a:tcPr>
+                    <a:solidFill>
+                      <a:srgbClr val="1B3A6B"/>
+                    </a:solidFill>
+                  </a:tcPr>
+                </a:tc>
+                <a:tc>
+                  <a:txBody>
+                    <a:bodyPr wrap="none"/>
+                    <a:lstStyle/>
+                    <a:p>
+                      <a:pPr algn="ctr"/>
+                      <a:r>
+                        <a:rPr sz="1000" b="1">
+                          <a:solidFill>
+                            <a:srgbClr val="FFFFFF"/>
+                          </a:solidFill>
+                        </a:rPr>
+                        <a:t>Annual Cost (IDR T)</a:t>
+                      </a:r>
+                    </a:p>
+                  </a:txBody>
+                  <a:tcPr>
+                    <a:solidFill>
+                      <a:srgbClr val="1B3A6B"/>
+                    </a:solidFill>
+                  </a:tcPr>
+                </a:tc>
+                <a:tc>
+                  <a:txBody>
+                    <a:bodyPr wrap="none"/>
+                    <a:lstStyle/>
+                    <a:p>
+                      <a:pPr algn="ctr"/>
+                      <a:r>
+                        <a:rPr sz="1000" b="1">
+                          <a:solidFill>
+                            <a:srgbClr val="FFFFFF"/>
+                          </a:solidFill>
+                        </a:rPr>
+                        <a:t>% of GDP</a:t>
+                      </a:r>
+                    </a:p>
+                  </a:txBody>
+                  <a:tcPr>
+                    <a:solidFill>
+                      <a:srgbClr val="1B3A6B"/>
+                    </a:solidFill>
+                  </a:tcPr>
+                </a:tc>
+                <a:tc>
+                  <a:txBody>
+                    <a:bodyPr wrap="none"/>
+                    <a:lstStyle/>
+                    <a:p>
+                      <a:pPr algn="ctr"/>
+                      <a:r>
+                        <a:rPr sz="1000" b="1">
+                          <a:solidFill>
+                            <a:srgbClr val="FFFFFF"/>
+                          </a:solidFill>
+                        </a:rPr>
+                        <a:t>20-Year Total (IDR T)</a:t>
+                      </a:r>
+                    </a:p>
+                  </a:txBody>
+                  <a:tcPr>
+                    <a:solidFill>
+                      <a:srgbClr val="1B3A6B"/>
+                    </a:solidFill>
+                  </a:tcPr>
+                </a:tc>
+                <a:tc>
+                  <a:txBody>
+                    <a:bodyPr wrap="none"/>
+                    <a:lstStyle/>
+                    <a:p>
+                      <a:pPr algn="ctr"/>
+                      <a:r>
+                        <a:rPr sz="1000" b="1">
+                          <a:solidFill>
+                            <a:srgbClr val="FFFFFF"/>
+                          </a:solidFill>
+                        </a:rPr>
+                        <a:t>Duration</a:t>
+                      </a:r>
+                    </a:p>
+                  </a:txBody>
+                  <a:tcPr>
+                    <a:solidFill>
+                      <a:srgbClr val="1B3A6B"/>
+                    </a:solidFill>
+                  </a:tcPr>
+                </a:tc>
+              </a:tr>
+              <a:tr h="512064">
+                <a:tc>
+                  <a:txBody>
+                    <a:bodyPr wrap="none"/>
+                    <a:lstStyle/>
+                    <a:p>
+                      <a:pPr algn="l"/>
+                      <a:r>
+                        <a:rPr sz="1000" b="0">
+                          <a:solidFill>
+                            <a:srgbClr val="000000"/>
+                          </a:solidFill>
+                        </a:rPr>
+                        <a:t>Tax Holiday (CIT)</a:t>
+                      </a:r>
+                    </a:p>
+                  </a:txBody>
+                  <a:tcPr>
+                    <a:solidFill>
+                      <a:srgbClr val="FFFFFF"/>
+                    </a:solidFill>
+                  </a:tcPr>
+                </a:tc>
+                <a:tc>
+                  <a:txBody>
+                    <a:bodyPr wrap="none"/>
+                    <a:lstStyle/>
+                    <a:p>
+                      <a:pPr algn="ctr"/>
+                      <a:r>
+                        <a:rPr sz="1000" b="0">
+                          <a:solidFill>
+                            <a:srgbClr val="000000"/>
+                          </a:solidFill>
+                        </a:rPr>
+                        <a:t>7.613</a:t>
+                      </a:r>
+                    </a:p>
+                  </a:txBody>
+                  <a:tcPr>
+                    <a:solidFill>
+                      <a:srgbClr val="FFFFFF"/>
+                    </a:solidFill>
+                  </a:tcPr>
+                </a:tc>
+                <a:tc>
+                  <a:txBody>
+                    <a:bodyPr wrap="none"/>
+                    <a:lstStyle/>
+                    <a:p>
+                      <a:pPr algn="ctr"/>
+                      <a:r>
+                        <a:rPr sz="1000" b="0">
+                          <a:solidFill>
+                            <a:srgbClr val="000000"/>
+                          </a:solidFill>
+                        </a:rPr>
+                        <a:t>0.034%</a:t>
+                      </a:r>
+                    </a:p>
+                  </a:txBody>
+                  <a:tcPr>
+                    <a:solidFill>
+                      <a:srgbClr val="FFFFFF"/>
+                    </a:solidFill>
+                  </a:tcPr>
+                </a:tc>
+                <a:tc>
+                  <a:txBody>
+                    <a:bodyPr wrap="none"/>
+                    <a:lstStyle/>
+                    <a:p>
+                      <a:pPr algn="ctr"/>
+                      <a:r>
+                        <a:rPr sz="1000" b="0">
+                          <a:solidFill>
+                            <a:srgbClr val="000000"/>
+                          </a:solidFill>
+                        </a:rPr>
+                        <a:t>118.234</a:t>
+                      </a:r>
+                    </a:p>
+                  </a:txBody>
+                  <a:tcPr>
+                    <a:solidFill>
+                      <a:srgbClr val="FFFFFF"/>
+                    </a:solidFill>
+                  </a:tcPr>
+                </a:tc>
+                <a:tc>
+                  <a:txBody>
+                    <a:bodyPr wrap="none"/>
+                    <a:lstStyle/>
+                    <a:p>
+                      <a:pPr algn="ctr"/>
+                      <a:r>
+                        <a:rPr sz="1000" b="0">
+                          <a:solidFill>
+                            <a:srgbClr val="000000"/>
+                          </a:solidFill>
+                        </a:rPr>
+                        <a:t>Up to 20 yrs</a:t>
+                      </a:r>
+                    </a:p>
+                  </a:txBody>
+                  <a:tcPr>
+                    <a:solidFill>
+                      <a:srgbClr val="FFFFFF"/>
+                    </a:solidFill>
+                  </a:tcPr>
+                </a:tc>
+              </a:tr>
+              <a:tr h="512064">
+                <a:tc>
+                  <a:txBody>
+                    <a:bodyPr wrap="none"/>
+                    <a:lstStyle/>
+                    <a:p>
+                      <a:pPr algn="l"/>
+                      <a:r>
+                        <a:rPr sz="1000" b="0">
+                          <a:solidFill>
+                            <a:srgbClr val="000000"/>
+                          </a:solidFill>
+                        </a:rPr>
+                        <a:t>Super Deduction (PP 78)</a:t>
+                      </a:r>
+                    </a:p>
+                  </a:txBody>
+                  <a:tcPr>
+                    <a:solidFill>
+                      <a:srgbClr val="F2F2F2"/>
+                    </a:solidFill>
+                  </a:tcPr>
+                </a:tc>
+                <a:tc>
+                  <a:txBody>
+                    <a:bodyPr wrap="none"/>
+                    <a:lstStyle/>
+                    <a:p>
+                      <a:pPr algn="ctr"/>
+                      <a:r>
+                        <a:rPr sz="1000" b="0">
+                          <a:solidFill>
+                            <a:srgbClr val="000000"/>
+                          </a:solidFill>
+                        </a:rPr>
+                        <a:t>3.174</a:t>
+                      </a:r>
+                    </a:p>
+                  </a:txBody>
+                  <a:tcPr>
+                    <a:solidFill>
+                      <a:srgbClr val="F2F2F2"/>
+                    </a:solidFill>
+                  </a:tcPr>
+                </a:tc>
+                <a:tc>
+                  <a:txBody>
+                    <a:bodyPr wrap="none"/>
+                    <a:lstStyle/>
+                    <a:p>
+                      <a:pPr algn="ctr"/>
+                      <a:r>
+                        <a:rPr sz="1000" b="0">
+                          <a:solidFill>
+                            <a:srgbClr val="000000"/>
+                          </a:solidFill>
+                        </a:rPr>
+                        <a:t>0.014%</a:t>
+                      </a:r>
+                    </a:p>
+                  </a:txBody>
+                  <a:tcPr>
+                    <a:solidFill>
+                      <a:srgbClr val="F2F2F2"/>
+                    </a:solidFill>
+                  </a:tcPr>
+                </a:tc>
+                <a:tc>
+                  <a:txBody>
+                    <a:bodyPr wrap="none"/>
+                    <a:lstStyle/>
+                    <a:p>
+                      <a:pPr algn="ctr"/>
+                      <a:r>
+                        <a:rPr sz="1000" b="0">
+                          <a:solidFill>
+                            <a:srgbClr val="000000"/>
+                          </a:solidFill>
+                        </a:rPr>
+                        <a:t>19.044</a:t>
+                      </a:r>
+                    </a:p>
+                  </a:txBody>
+                  <a:tcPr>
+                    <a:solidFill>
+                      <a:srgbClr val="F2F2F2"/>
+                    </a:solidFill>
+                  </a:tcPr>
+                </a:tc>
+                <a:tc>
+                  <a:txBody>
+                    <a:bodyPr wrap="none"/>
+                    <a:lstStyle/>
+                    <a:p>
+                      <a:pPr algn="ctr"/>
+                      <a:r>
+                        <a:rPr sz="1000" b="0">
+                          <a:solidFill>
+                            <a:srgbClr val="000000"/>
+                          </a:solidFill>
+                        </a:rPr>
+                        <a:t>6 yrs post-holiday</a:t>
+                      </a:r>
+                    </a:p>
+                  </a:txBody>
+                  <a:tcPr>
+                    <a:solidFill>
+                      <a:srgbClr val="F2F2F2"/>
+                    </a:solidFill>
+                  </a:tcPr>
+                </a:tc>
+              </a:tr>
+              <a:tr h="512064">
+                <a:tc>
+                  <a:txBody>
+                    <a:bodyPr wrap="none"/>
+                    <a:lstStyle/>
+                    <a:p>
+                      <a:pPr algn="l"/>
+                      <a:r>
+                        <a:rPr sz="1000" b="0">
+                          <a:solidFill>
+                            <a:srgbClr val="000000"/>
+                          </a:solidFill>
+                        </a:rPr>
+                        <a:t>SEZ VAT Exemption</a:t>
+                      </a:r>
+                    </a:p>
+                  </a:txBody>
+                  <a:tcPr>
+                    <a:solidFill>
+                      <a:srgbClr val="FFFFFF"/>
+                    </a:solidFill>
+                  </a:tcPr>
+                </a:tc>
+                <a:tc>
+                  <a:txBody>
+                    <a:bodyPr wrap="none"/>
+                    <a:lstStyle/>
+                    <a:p>
+                      <a:pPr algn="ctr"/>
+                      <a:r>
+                        <a:rPr sz="1000" b="0">
+                          <a:solidFill>
+                            <a:srgbClr val="000000"/>
+                          </a:solidFill>
+                        </a:rPr>
+                        <a:t>0.265</a:t>
+                      </a:r>
+                    </a:p>
+                  </a:txBody>
+                  <a:tcPr>
+                    <a:solidFill>
+                      <a:srgbClr val="FFFFFF"/>
+                    </a:solidFill>
+                  </a:tcPr>
+                </a:tc>
+                <a:tc>
+                  <a:txBody>
+                    <a:bodyPr wrap="none"/>
+                    <a:lstStyle/>
+                    <a:p>
+                      <a:pPr algn="ctr"/>
+                      <a:r>
+                        <a:rPr sz="1000" b="0">
+                          <a:solidFill>
+                            <a:srgbClr val="000000"/>
+                          </a:solidFill>
+                        </a:rPr>
+                        <a:t>0.001%</a:t>
+                      </a:r>
+                    </a:p>
+                  </a:txBody>
+                  <a:tcPr>
+                    <a:solidFill>
+                      <a:srgbClr val="FFFFFF"/>
+                    </a:solidFill>
+                  </a:tcPr>
+                </a:tc>
+                <a:tc>
+                  <a:txBody>
+                    <a:bodyPr wrap="none"/>
+                    <a:lstStyle/>
+                    <a:p>
+                      <a:pPr algn="ctr"/>
+                      <a:r>
+                        <a:rPr sz="1000" b="0">
+                          <a:solidFill>
+                            <a:srgbClr val="000000"/>
+                          </a:solidFill>
+                        </a:rPr>
+                        <a:t>0.796</a:t>
+                      </a:r>
+                    </a:p>
+                  </a:txBody>
+                  <a:tcPr>
+                    <a:solidFill>
+                      <a:srgbClr val="FFFFFF"/>
+                    </a:solidFill>
+                  </a:tcPr>
+                </a:tc>
+                <a:tc>
+                  <a:txBody>
+                    <a:bodyPr wrap="none"/>
+                    <a:lstStyle/>
+                    <a:p>
+                      <a:pPr algn="ctr"/>
+                      <a:r>
+                        <a:rPr sz="1000" b="0">
+                          <a:solidFill>
+                            <a:srgbClr val="000000"/>
+                          </a:solidFill>
+                        </a:rPr>
+                        <a:t>One-off (3-yr build)</a:t>
+                      </a:r>
+                    </a:p>
+                  </a:txBody>
+                  <a:tcPr>
+                    <a:solidFill>
+                      <a:srgbClr val="FFFFFF"/>
+                    </a:solidFill>
+                  </a:tcPr>
+                </a:tc>
+              </a:tr>
+              <a:tr h="512064">
+                <a:tc>
+                  <a:txBody>
+                    <a:bodyPr wrap="none"/>
+                    <a:lstStyle/>
+                    <a:p>
+                      <a:pPr algn="l"/>
+                      <a:r>
+                        <a:rPr sz="1000" b="1">
+                          <a:solidFill>
+                            <a:srgbClr val="FFFFFF"/>
+                          </a:solidFill>
+                        </a:rPr>
+                        <a:t>Grand Total</a:t>
+                      </a:r>
+                    </a:p>
+                  </a:txBody>
+                  <a:tcPr>
+                    <a:solidFill>
+                      <a:srgbClr val="1B3A6B"/>
+                    </a:solidFill>
+                  </a:tcPr>
+                </a:tc>
+                <a:tc>
+                  <a:txBody>
+                    <a:bodyPr wrap="none"/>
+                    <a:lstStyle/>
+                    <a:p>
+                      <a:pPr algn="ctr"/>
+                      <a:r>
+                        <a:rPr sz="1000" b="1">
+                          <a:solidFill>
+                            <a:srgbClr val="FFFFFF"/>
+                          </a:solidFill>
+                        </a:rPr>
+                        <a:t>11.052</a:t>
+                      </a:r>
+                    </a:p>
+                  </a:txBody>
+                  <a:tcPr>
+                    <a:solidFill>
+                      <a:srgbClr val="1B3A6B"/>
+                    </a:solidFill>
+                  </a:tcPr>
+                </a:tc>
+                <a:tc>
+                  <a:txBody>
+                    <a:bodyPr wrap="none"/>
+                    <a:lstStyle/>
+                    <a:p>
+                      <a:pPr algn="ctr"/>
+                      <a:r>
+                        <a:rPr sz="1000" b="1">
+                          <a:solidFill>
+                            <a:srgbClr val="FFFFFF"/>
+                          </a:solidFill>
+                        </a:rPr>
+                        <a:t>0.050%</a:t>
+                      </a:r>
+                    </a:p>
+                  </a:txBody>
+                  <a:tcPr>
+                    <a:solidFill>
+                      <a:srgbClr val="1B3A6B"/>
+                    </a:solidFill>
+                  </a:tcPr>
+                </a:tc>
+                <a:tc>
+                  <a:txBody>
+                    <a:bodyPr wrap="none"/>
+                    <a:lstStyle/>
+                    <a:p>
+                      <a:pPr algn="ctr"/>
+                      <a:r>
+                        <a:rPr sz="1000" b="1">
+                          <a:solidFill>
+                            <a:srgbClr val="FFFFFF"/>
+                          </a:solidFill>
+                        </a:rPr>
+                        <a:t>138.074</a:t>
+                      </a:r>
+                    </a:p>
+                  </a:txBody>
+                  <a:tcPr>
+                    <a:solidFill>
+                      <a:srgbClr val="1B3A6B"/>
+                    </a:solidFill>
+                  </a:tcPr>
+                </a:tc>
+                <a:tc>
+                  <a:txBody>
+                    <a:bodyPr wrap="none"/>
+                    <a:lstStyle/>
+                    <a:p>
+                      <a:pPr algn="ctr"/>
+                      <a:r>
+                        <a:rPr sz="1000" b="1">
+                          <a:solidFill>
+                            <a:srgbClr val="FFFFFF"/>
+                          </a:solidFill>
+                        </a:rPr>
+                        <a:t>---</a:t>
+                      </a:r>
+                    </a:p>
+                  </a:txBody>
+                  <a:tcPr>
+                    <a:solidFill>
+                      <a:srgbClr val="1B3A6B"/>
+                    </a:solidFill>
+                  </a:tcPr>
+                </a:tc>
+              </a:tr>
+            </a:tbl>
+          </a:graphicData>
+        </a:graphic>
+      </p:graphicFrame>
+      <p:sp>
+        <p:nvSpPr>
+          <p:cNvPr id="4" name="TextBox 3"/>
+          <p:cNvSpPr txBox="1"/>
+          <p:nvPr/>
+        </p:nvSpPr>
+        <p:spPr>
+          <a:xfrm>
+            <a:off x="365760" y="3794760"/>
+            <a:ext cx="5728716" cy="594360"/>
+          </a:xfrm>
+          <a:prstGeom prst="rect">
+            <a:avLst/>
+          </a:prstGeom>
+          <a:noFill/>
+        </p:spPr>
+        <p:txBody>
+          <a:bodyPr wrap="square">
+            <a:spAutoFit/>
+          </a:bodyPr>
+          <a:lstStyle/>
+          <a:p>
+            <a:pPr algn="l"/>
+            <a:r>
+              <a:rPr sz="800" b="0">
+                <a:solidFill>
+                  <a:srgbClr val="1B3A6B"/>
+                </a:solidFill>
+              </a:rPr>
+              <a:t>Annual cost = sum across all facilities of
+(investment × 12% × CIT-forfeited rate).
+Tax Holiday run-rate = all active/committed holidays.</a:t>
+            </a:r>
+          </a:p>
+        </p:txBody>
+      </p:sp>
+      <p:sp>
+        <p:nvSpPr>
+          <p:cNvPr id="5" name="TextBox 4"/>
+          <p:cNvSpPr txBox="1"/>
+          <p:nvPr/>
+        </p:nvSpPr>
+        <p:spPr>
+          <a:xfrm>
+            <a:off x="6323624" y="3794760"/>
+            <a:ext cx="5499567" cy="594360"/>
+          </a:xfrm>
+          <a:prstGeom prst="rect">
+            <a:avLst/>
+          </a:prstGeom>
+          <a:noFill/>
+        </p:spPr>
+        <p:txBody>
+          <a:bodyPr wrap="square">
+            <a:spAutoFit/>
+          </a:bodyPr>
+          <a:lstStyle/>
+          <a:p>
+            <a:pPr algn="l"/>
+            <a:r>
+              <a:rPr sz="800" b="0">
+                <a:solidFill>
+                  <a:srgbClr val="1B3A6B"/>
+                </a:solidFill>
+              </a:rPr>
+              <a:t>Indonesia 2024 GDP = IDR 22,139T (BPS).
+20-year totals cover full contractual periods,
+not a uniform 20-year stream.</a:t>
+            </a:r>
+          </a:p>
+        </p:txBody>
+      </p:sp>
+    </p:spTree>
+  </p:cSld>
+  <p:clrMapOvr>
+    <a:masterClrMapping/>
+  </p:clrMapOvr>
+</p:sld>
+</file>
+
+<file path=ppt/slides/slide3.xml><?xml version="1.0" encoding="utf-8"?>
+<p:sld xmlns:a="http://schemas.openxmlformats.org/drawingml/2006/main" xmlns:p="http://schemas.openxmlformats.org/presentationml/2006/main" xmlns:r="http://schemas.openxmlformats.org/officeDocument/2006/relationships">
+  <p:cSld>
+    <p:spTree>
+      <p:nvGrpSpPr>
+        <p:cNvPr id="1" name=""/>
+        <p:cNvGrpSpPr/>
+        <p:nvPr/>
+      </p:nvGrpSpPr>
+      <p:grpSpPr/>
+      <p:sp>
+        <p:nvSpPr>
+          <p:cNvPr id="2" name="Rectangle 1"/>
+          <p:cNvSpPr/>
+          <p:nvPr/>
+        </p:nvSpPr>
+        <p:spPr>
+          <a:xfrm>
+            <a:off x="0" y="137160"/>
+            <a:ext cx="12188952" cy="594360"/>
+          </a:xfrm>
+          <a:prstGeom prst="rect">
+            <a:avLst/>
+          </a:prstGeom>
+          <a:solidFill>
+            <a:srgbClr val="1B3A6B"/>
+          </a:solidFill>
+          <a:ln>
+            <a:solidFill>
+              <a:srgbClr val="1B3A6B"/>
+            </a:solidFill>
+          </a:ln>
+        </p:spPr>
+        <p:style>
+          <a:lnRef idx="1">
+            <a:schemeClr val="accent1"/>
+          </a:lnRef>
+          <a:fillRef idx="3">
+            <a:schemeClr val="accent1"/>
+          </a:fillRef>
+          <a:effectRef idx="2">
+            <a:schemeClr val="accent1"/>
+          </a:effectRef>
+          <a:fontRef idx="minor">
+            <a:schemeClr val="lt1"/>
+          </a:fontRef>
+        </p:style>
+        <p:txBody>
+          <a:bodyPr rtlCol="0" anchor="ctr" wrap="none"/>
+          <a:lstStyle/>
+          <a:p>
+            <a:pPr algn="l"/>
+            <a:r>
+              <a:rPr sz="1800" b="1">
+                <a:solidFill>
+                  <a:srgbClr val="FFFFFF"/>
+                </a:solidFill>
+              </a:rPr>
               <a:t>  Fiscal Cost by Investment Tier</a:t>
             </a:r>
           </a:p>
@@ -6065,7 +6798,7 @@
 </p:sld>
 </file>
 
-<file path=ppt/slides/slide3.xml><?xml version="1.0" encoding="utf-8"?>
+<file path=ppt/slides/slide4.xml><?xml version="1.0" encoding="utf-8"?>
 <p:sld xmlns:a="http://schemas.openxmlformats.org/drawingml/2006/main" xmlns:p="http://schemas.openxmlformats.org/presentationml/2006/main" xmlns:r="http://schemas.openxmlformats.org/officeDocument/2006/relationships">
   <p:cSld>
     <p:spTree>

</xml_diff>

<commit_message>
Regenerate all output files with updated policy scenarios and add make_docx.py
- Add Fiscal Scenarios slide (A=2000MW, B=3000MW, VAT/Combined) to make_slides.py
- Regenerate fiscal_slides.pptx with 5-slide deck including new scenarios slide
- Fix baseline 18.0T→18.1T and Combined A/B totals (64.2T, 93.3T) in fiscal_slides.tex
- Fix fiscal_report.tex: tabularx centering, uppercase/MIDGRAY, and euro symbol errors
- Recompile all PDFs: fiscal_cost_report, fiscal_slides, fiscal_report, indonesia_dc_report, indonesia_dc_slides
- Add make_docx.py to generate fiscal_cost_report.docx via python-docx
- Regenerate fiscal_cost_report.docx with correct A=2000MW/B=3000MW/VAT=Combined scenario table

https://claude.ai/code/session_018m2ceypEakZpmjRE2PTWZv
</commit_message>
<xml_diff>
--- a/reports/fiscal_slides.pptx
+++ b/reports/fiscal_slides.pptx
@@ -9,6 +9,7 @@
     <p:sldId id="257" r:id="rId8"/>
     <p:sldId id="258" r:id="rId9"/>
     <p:sldId id="259" r:id="rId10"/>
+    <p:sldId id="260" r:id="rId11"/>
   </p:sldIdLst>
   <p:sldSz cx="12188952" cy="6858000" type="screen4x3"/>
   <p:notesSz cx="6858000" cy="9144000"/>
@@ -6799,6 +6800,1755 @@
 </file>
 
 <file path=ppt/slides/slide4.xml><?xml version="1.0" encoding="utf-8"?>
+<p:sld xmlns:a="http://schemas.openxmlformats.org/drawingml/2006/main" xmlns:p="http://schemas.openxmlformats.org/presentationml/2006/main" xmlns:r="http://schemas.openxmlformats.org/officeDocument/2006/relationships">
+  <p:cSld>
+    <p:spTree>
+      <p:nvGrpSpPr>
+        <p:cNvPr id="1" name=""/>
+        <p:cNvGrpSpPr/>
+        <p:nvPr/>
+      </p:nvGrpSpPr>
+      <p:grpSpPr/>
+      <p:sp>
+        <p:nvSpPr>
+          <p:cNvPr id="2" name="Rectangle 1"/>
+          <p:cNvSpPr/>
+          <p:nvPr/>
+        </p:nvSpPr>
+        <p:spPr>
+          <a:xfrm>
+            <a:off x="0" y="137160"/>
+            <a:ext cx="12188952" cy="594360"/>
+          </a:xfrm>
+          <a:prstGeom prst="rect">
+            <a:avLst/>
+          </a:prstGeom>
+          <a:solidFill>
+            <a:srgbClr val="1B3A6B"/>
+          </a:solidFill>
+          <a:ln>
+            <a:solidFill>
+              <a:srgbClr val="1B3A6B"/>
+            </a:solidFill>
+          </a:ln>
+        </p:spPr>
+        <p:style>
+          <a:lnRef idx="1">
+            <a:schemeClr val="accent1"/>
+          </a:lnRef>
+          <a:fillRef idx="3">
+            <a:schemeClr val="accent1"/>
+          </a:fillRef>
+          <a:effectRef idx="2">
+            <a:schemeClr val="accent1"/>
+          </a:effectRef>
+          <a:fontRef idx="minor">
+            <a:schemeClr val="lt1"/>
+          </a:fontRef>
+        </p:style>
+        <p:txBody>
+          <a:bodyPr rtlCol="0" anchor="ctr" wrap="none"/>
+          <a:lstStyle/>
+          <a:p>
+            <a:pPr algn="l"/>
+            <a:r>
+              <a:rPr sz="1800" b="1">
+                <a:solidFill>
+                  <a:srgbClr val="FFFFFF"/>
+                </a:solidFill>
+              </a:rPr>
+              <a:t>  Fiscal Scenarios: Cost Projections (A &amp; B)</a:t>
+            </a:r>
+          </a:p>
+        </p:txBody>
+      </p:sp>
+      <p:sp>
+        <p:nvSpPr>
+          <p:cNvPr id="3" name="TextBox 2"/>
+          <p:cNvSpPr txBox="1"/>
+          <p:nvPr/>
+        </p:nvSpPr>
+        <p:spPr>
+          <a:xfrm>
+            <a:off x="320040" y="841248"/>
+            <a:ext cx="5577840" cy="228600"/>
+          </a:xfrm>
+          <a:prstGeom prst="rect">
+            <a:avLst/>
+          </a:prstGeom>
+          <a:noFill/>
+        </p:spPr>
+        <p:txBody>
+          <a:bodyPr wrap="square">
+            <a:spAutoFit/>
+          </a:bodyPr>
+          <a:lstStyle/>
+          <a:p>
+            <a:pPr algn="l"/>
+            <a:r>
+              <a:rPr sz="1000" b="1">
+                <a:solidFill>
+                  <a:srgbClr val="1B3A6B"/>
+                </a:solidFill>
+              </a:rPr>
+              <a:t>Scenario A — Expansion to 2,000 MW (2030)</a:t>
+            </a:r>
+          </a:p>
+        </p:txBody>
+      </p:sp>
+      <p:sp>
+        <p:nvSpPr>
+          <p:cNvPr id="4" name="TextBox 3"/>
+          <p:cNvSpPr txBox="1"/>
+          <p:nvPr/>
+        </p:nvSpPr>
+        <p:spPr>
+          <a:xfrm>
+            <a:off x="320040" y="1078992"/>
+            <a:ext cx="5577840" cy="256032"/>
+          </a:xfrm>
+          <a:prstGeom prst="rect">
+            <a:avLst/>
+          </a:prstGeom>
+          <a:noFill/>
+        </p:spPr>
+        <p:txBody>
+          <a:bodyPr wrap="square">
+            <a:spAutoFit/>
+          </a:bodyPr>
+          <a:lstStyle/>
+          <a:p>
+            <a:pPr algn="l"/>
+            <a:r>
+              <a:rPr sz="800" b="0">
+                <a:solidFill>
+                  <a:srgbClr val="000000"/>
+                </a:solidFill>
+              </a:rPr>
+              <a:t>+1,474 MW from 526 MW base at IDR 111B/MW; 43% GMT / 57% non-GMT, 10-yr holiday.</a:t>
+            </a:r>
+          </a:p>
+        </p:txBody>
+      </p:sp>
+      <p:graphicFrame>
+        <p:nvGraphicFramePr>
+          <p:cNvPr id="5" name="Table 4"/>
+          <p:cNvGraphicFramePr>
+            <a:graphicFrameLocks noGrp="1"/>
+          </p:cNvGraphicFramePr>
+          <p:nvPr/>
+        </p:nvGraphicFramePr>
+        <p:xfrm>
+          <a:off x="320040" y="1371600"/>
+          <a:ext cx="5577840" cy="1874519"/>
+        </p:xfrm>
+        <a:graphic>
+          <a:graphicData uri="http://schemas.openxmlformats.org/drawingml/2006/table">
+            <a:tbl>
+              <a:tblPr firstRow="1" bandRow="1">
+                <a:tableStyleId>{5C22544A-7EE6-4342-B048-85BDC9FD1C3A}</a:tableStyleId>
+              </a:tblPr>
+              <a:tblGrid>
+                <a:gridCol w="3346704"/>
+                <a:gridCol w="2231136"/>
+              </a:tblGrid>
+              <a:tr h="267788">
+                <a:tc>
+                  <a:txBody>
+                    <a:bodyPr wrap="none"/>
+                    <a:lstStyle/>
+                    <a:p>
+                      <a:pPr algn="l"/>
+                      <a:r>
+                        <a:rPr sz="850" b="1">
+                          <a:solidFill>
+                            <a:srgbClr val="FFFFFF"/>
+                          </a:solidFill>
+                        </a:rPr>
+                        <a:t>Metric</a:t>
+                      </a:r>
+                    </a:p>
+                  </a:txBody>
+                  <a:tcPr>
+                    <a:solidFill>
+                      <a:srgbClr val="1B3A6B"/>
+                    </a:solidFill>
+                  </a:tcPr>
+                </a:tc>
+                <a:tc>
+                  <a:txBody>
+                    <a:bodyPr wrap="none"/>
+                    <a:lstStyle/>
+                    <a:p>
+                      <a:pPr algn="ctr"/>
+                      <a:r>
+                        <a:rPr sz="850" b="1">
+                          <a:solidFill>
+                            <a:srgbClr val="FFFFFF"/>
+                          </a:solidFill>
+                        </a:rPr>
+                        <a:t>Value</a:t>
+                      </a:r>
+                    </a:p>
+                  </a:txBody>
+                  <a:tcPr>
+                    <a:solidFill>
+                      <a:srgbClr val="1B3A6B"/>
+                    </a:solidFill>
+                  </a:tcPr>
+                </a:tc>
+              </a:tr>
+              <a:tr h="267788">
+                <a:tc>
+                  <a:txBody>
+                    <a:bodyPr wrap="none"/>
+                    <a:lstStyle/>
+                    <a:p>
+                      <a:pPr algn="l"/>
+                      <a:r>
+                        <a:rPr sz="850" b="0">
+                          <a:solidFill>
+                            <a:srgbClr val="000000"/>
+                          </a:solidFill>
+                        </a:rPr>
+                        <a:t>Baseline MW (operational)</a:t>
+                      </a:r>
+                    </a:p>
+                  </a:txBody>
+                  <a:tcPr>
+                    <a:solidFill>
+                      <a:srgbClr val="FFFFFF"/>
+                    </a:solidFill>
+                  </a:tcPr>
+                </a:tc>
+                <a:tc>
+                  <a:txBody>
+                    <a:bodyPr wrap="none"/>
+                    <a:lstStyle/>
+                    <a:p>
+                      <a:pPr algn="ctr"/>
+                      <a:r>
+                        <a:rPr sz="850" b="0">
+                          <a:solidFill>
+                            <a:srgbClr val="000000"/>
+                          </a:solidFill>
+                        </a:rPr>
+                        <a:t>526 MW</a:t>
+                      </a:r>
+                    </a:p>
+                  </a:txBody>
+                  <a:tcPr>
+                    <a:solidFill>
+                      <a:srgbClr val="FFFFFF"/>
+                    </a:solidFill>
+                  </a:tcPr>
+                </a:tc>
+              </a:tr>
+              <a:tr h="267788">
+                <a:tc>
+                  <a:txBody>
+                    <a:bodyPr wrap="none"/>
+                    <a:lstStyle/>
+                    <a:p>
+                      <a:pPr algn="l"/>
+                      <a:r>
+                        <a:rPr sz="850" b="0">
+                          <a:solidFill>
+                            <a:srgbClr val="000000"/>
+                          </a:solidFill>
+                        </a:rPr>
+                        <a:t>Baseline annual cost</a:t>
+                      </a:r>
+                    </a:p>
+                  </a:txBody>
+                  <a:tcPr>
+                    <a:solidFill>
+                      <a:srgbClr val="F2F2F2"/>
+                    </a:solidFill>
+                  </a:tcPr>
+                </a:tc>
+                <a:tc>
+                  <a:txBody>
+                    <a:bodyPr wrap="none"/>
+                    <a:lstStyle/>
+                    <a:p>
+                      <a:pPr algn="ctr"/>
+                      <a:r>
+                        <a:rPr sz="850" b="0">
+                          <a:solidFill>
+                            <a:srgbClr val="000000"/>
+                          </a:solidFill>
+                        </a:rPr>
+                        <a:t>IDR 1.57T</a:t>
+                      </a:r>
+                    </a:p>
+                  </a:txBody>
+                  <a:tcPr>
+                    <a:solidFill>
+                      <a:srgbClr val="F2F2F2"/>
+                    </a:solidFill>
+                  </a:tcPr>
+                </a:tc>
+              </a:tr>
+              <a:tr h="267788">
+                <a:tc>
+                  <a:txBody>
+                    <a:bodyPr wrap="none"/>
+                    <a:lstStyle/>
+                    <a:p>
+                      <a:pPr algn="l"/>
+                      <a:r>
+                        <a:rPr sz="850" b="1">
+                          <a:solidFill>
+                            <a:srgbClr val="000000"/>
+                          </a:solidFill>
+                        </a:rPr>
+                        <a:t>2030 annual cost (2,000 MW)</a:t>
+                      </a:r>
+                    </a:p>
+                  </a:txBody>
+                  <a:tcPr>
+                    <a:solidFill>
+                      <a:srgbClr val="FFFFFF"/>
+                    </a:solidFill>
+                  </a:tcPr>
+                </a:tc>
+                <a:tc>
+                  <a:txBody>
+                    <a:bodyPr wrap="none"/>
+                    <a:lstStyle/>
+                    <a:p>
+                      <a:pPr algn="ctr"/>
+                      <a:r>
+                        <a:rPr sz="850" b="1">
+                          <a:solidFill>
+                            <a:srgbClr val="000000"/>
+                          </a:solidFill>
+                        </a:rPr>
+                        <a:t>IDR 4.62T</a:t>
+                      </a:r>
+                    </a:p>
+                  </a:txBody>
+                  <a:tcPr>
+                    <a:solidFill>
+                      <a:srgbClr val="FFFFFF"/>
+                    </a:solidFill>
+                  </a:tcPr>
+                </a:tc>
+              </a:tr>
+              <a:tr h="267788">
+                <a:tc>
+                  <a:txBody>
+                    <a:bodyPr wrap="none"/>
+                    <a:lstStyle/>
+                    <a:p>
+                      <a:pPr algn="l"/>
+                      <a:r>
+                        <a:rPr sz="850" b="0">
+                          <a:solidFill>
+                            <a:srgbClr val="000000"/>
+                          </a:solidFill>
+                        </a:rPr>
+                        <a:t>% 2024 GDP</a:t>
+                      </a:r>
+                    </a:p>
+                  </a:txBody>
+                  <a:tcPr>
+                    <a:solidFill>
+                      <a:srgbClr val="F2F2F2"/>
+                    </a:solidFill>
+                  </a:tcPr>
+                </a:tc>
+                <a:tc>
+                  <a:txBody>
+                    <a:bodyPr wrap="none"/>
+                    <a:lstStyle/>
+                    <a:p>
+                      <a:pPr algn="ctr"/>
+                      <a:r>
+                        <a:rPr sz="850" b="0">
+                          <a:solidFill>
+                            <a:srgbClr val="000000"/>
+                          </a:solidFill>
+                        </a:rPr>
+                        <a:t>0.021%</a:t>
+                      </a:r>
+                    </a:p>
+                  </a:txBody>
+                  <a:tcPr>
+                    <a:solidFill>
+                      <a:srgbClr val="F2F2F2"/>
+                    </a:solidFill>
+                  </a:tcPr>
+                </a:tc>
+              </a:tr>
+              <a:tr h="267788">
+                <a:tc>
+                  <a:txBody>
+                    <a:bodyPr wrap="none"/>
+                    <a:lstStyle/>
+                    <a:p>
+                      <a:pPr algn="l"/>
+                      <a:r>
+                        <a:rPr sz="850" b="0">
+                          <a:solidFill>
+                            <a:srgbClr val="000000"/>
+                          </a:solidFill>
+                        </a:rPr>
+                        <a:t>% 2030 GDP (est.)</a:t>
+                      </a:r>
+                    </a:p>
+                  </a:txBody>
+                  <a:tcPr>
+                    <a:solidFill>
+                      <a:srgbClr val="FFFFFF"/>
+                    </a:solidFill>
+                  </a:tcPr>
+                </a:tc>
+                <a:tc>
+                  <a:txBody>
+                    <a:bodyPr wrap="none"/>
+                    <a:lstStyle/>
+                    <a:p>
+                      <a:pPr algn="ctr"/>
+                      <a:r>
+                        <a:rPr sz="850" b="0">
+                          <a:solidFill>
+                            <a:srgbClr val="000000"/>
+                          </a:solidFill>
+                        </a:rPr>
+                        <a:t>0.014%</a:t>
+                      </a:r>
+                    </a:p>
+                  </a:txBody>
+                  <a:tcPr>
+                    <a:solidFill>
+                      <a:srgbClr val="FFFFFF"/>
+                    </a:solidFill>
+                  </a:tcPr>
+                </a:tc>
+              </a:tr>
+              <a:tr h="267791">
+                <a:tc>
+                  <a:txBody>
+                    <a:bodyPr wrap="none"/>
+                    <a:lstStyle/>
+                    <a:p>
+                      <a:pPr algn="l"/>
+                      <a:r>
+                        <a:rPr sz="850" b="0">
+                          <a:solidFill>
+                            <a:srgbClr val="000000"/>
+                          </a:solidFill>
+                        </a:rPr>
+                        <a:t>Scenario A cumulative</a:t>
+                      </a:r>
+                    </a:p>
+                  </a:txBody>
+                  <a:tcPr>
+                    <a:solidFill>
+                      <a:srgbClr val="F2F2F2"/>
+                    </a:solidFill>
+                  </a:tcPr>
+                </a:tc>
+                <a:tc>
+                  <a:txBody>
+                    <a:bodyPr wrap="none"/>
+                    <a:lstStyle/>
+                    <a:p>
+                      <a:pPr algn="ctr"/>
+                      <a:r>
+                        <a:rPr sz="850" b="0">
+                          <a:solidFill>
+                            <a:srgbClr val="000000"/>
+                          </a:solidFill>
+                        </a:rPr>
+                        <a:t>IDR 53.2T</a:t>
+                      </a:r>
+                    </a:p>
+                  </a:txBody>
+                  <a:tcPr>
+                    <a:solidFill>
+                      <a:srgbClr val="F2F2F2"/>
+                    </a:solidFill>
+                  </a:tcPr>
+                </a:tc>
+              </a:tr>
+            </a:tbl>
+          </a:graphicData>
+        </a:graphic>
+      </p:graphicFrame>
+      <p:sp>
+        <p:nvSpPr>
+          <p:cNvPr id="6" name="TextBox 5"/>
+          <p:cNvSpPr txBox="1"/>
+          <p:nvPr/>
+        </p:nvSpPr>
+        <p:spPr>
+          <a:xfrm>
+            <a:off x="320040" y="3364992"/>
+            <a:ext cx="5577840" cy="228600"/>
+          </a:xfrm>
+          <a:prstGeom prst="rect">
+            <a:avLst/>
+          </a:prstGeom>
+          <a:noFill/>
+        </p:spPr>
+        <p:txBody>
+          <a:bodyPr wrap="square">
+            <a:spAutoFit/>
+          </a:bodyPr>
+          <a:lstStyle/>
+          <a:p>
+            <a:pPr algn="l"/>
+            <a:r>
+              <a:rPr sz="1000" b="1">
+                <a:solidFill>
+                  <a:srgbClr val="1B3A6B"/>
+                </a:solidFill>
+              </a:rPr>
+              <a:t>Scenario B — Expansion to 3,000 MW (2030)</a:t>
+            </a:r>
+          </a:p>
+        </p:txBody>
+      </p:sp>
+      <p:sp>
+        <p:nvSpPr>
+          <p:cNvPr id="7" name="TextBox 6"/>
+          <p:cNvSpPr txBox="1"/>
+          <p:nvPr/>
+        </p:nvSpPr>
+        <p:spPr>
+          <a:xfrm>
+            <a:off x="320040" y="3602736"/>
+            <a:ext cx="5577840" cy="228600"/>
+          </a:xfrm>
+          <a:prstGeom prst="rect">
+            <a:avLst/>
+          </a:prstGeom>
+          <a:noFill/>
+        </p:spPr>
+        <p:txBody>
+          <a:bodyPr wrap="square">
+            <a:spAutoFit/>
+          </a:bodyPr>
+          <a:lstStyle/>
+          <a:p>
+            <a:pPr algn="l"/>
+            <a:r>
+              <a:rPr sz="800" b="0">
+                <a:solidFill>
+                  <a:srgbClr val="000000"/>
+                </a:solidFill>
+              </a:rPr>
+              <a:t>+2,474 MW from 526 MW base; same mix and holiday as Scenario A.</a:t>
+            </a:r>
+          </a:p>
+        </p:txBody>
+      </p:sp>
+      <p:graphicFrame>
+        <p:nvGraphicFramePr>
+          <p:cNvPr id="8" name="Table 7"/>
+          <p:cNvGraphicFramePr>
+            <a:graphicFrameLocks noGrp="1"/>
+          </p:cNvGraphicFramePr>
+          <p:nvPr/>
+        </p:nvGraphicFramePr>
+        <p:xfrm>
+          <a:off x="320040" y="3858768"/>
+          <a:ext cx="5577840" cy="1417320"/>
+        </p:xfrm>
+        <a:graphic>
+          <a:graphicData uri="http://schemas.openxmlformats.org/drawingml/2006/table">
+            <a:tbl>
+              <a:tblPr firstRow="1" bandRow="1">
+                <a:tableStyleId>{5C22544A-7EE6-4342-B048-85BDC9FD1C3A}</a:tableStyleId>
+              </a:tblPr>
+              <a:tblGrid>
+                <a:gridCol w="3346704"/>
+                <a:gridCol w="2231136"/>
+              </a:tblGrid>
+              <a:tr h="283464">
+                <a:tc>
+                  <a:txBody>
+                    <a:bodyPr wrap="none"/>
+                    <a:lstStyle/>
+                    <a:p>
+                      <a:pPr algn="l"/>
+                      <a:r>
+                        <a:rPr sz="850" b="1">
+                          <a:solidFill>
+                            <a:srgbClr val="FFFFFF"/>
+                          </a:solidFill>
+                        </a:rPr>
+                        <a:t>Metric</a:t>
+                      </a:r>
+                    </a:p>
+                  </a:txBody>
+                  <a:tcPr>
+                    <a:solidFill>
+                      <a:srgbClr val="1B3A6B"/>
+                    </a:solidFill>
+                  </a:tcPr>
+                </a:tc>
+                <a:tc>
+                  <a:txBody>
+                    <a:bodyPr wrap="none"/>
+                    <a:lstStyle/>
+                    <a:p>
+                      <a:pPr algn="ctr"/>
+                      <a:r>
+                        <a:rPr sz="850" b="1">
+                          <a:solidFill>
+                            <a:srgbClr val="FFFFFF"/>
+                          </a:solidFill>
+                        </a:rPr>
+                        <a:t>Value</a:t>
+                      </a:r>
+                    </a:p>
+                  </a:txBody>
+                  <a:tcPr>
+                    <a:solidFill>
+                      <a:srgbClr val="1B3A6B"/>
+                    </a:solidFill>
+                  </a:tcPr>
+                </a:tc>
+              </a:tr>
+              <a:tr h="283464">
+                <a:tc>
+                  <a:txBody>
+                    <a:bodyPr wrap="none"/>
+                    <a:lstStyle/>
+                    <a:p>
+                      <a:pPr algn="l"/>
+                      <a:r>
+                        <a:rPr sz="850" b="1">
+                          <a:solidFill>
+                            <a:srgbClr val="000000"/>
+                          </a:solidFill>
+                        </a:rPr>
+                        <a:t>2030 annual cost (3,000 MW)</a:t>
+                      </a:r>
+                    </a:p>
+                  </a:txBody>
+                  <a:tcPr>
+                    <a:solidFill>
+                      <a:srgbClr val="FFFFFF"/>
+                    </a:solidFill>
+                  </a:tcPr>
+                </a:tc>
+                <a:tc>
+                  <a:txBody>
+                    <a:bodyPr wrap="none"/>
+                    <a:lstStyle/>
+                    <a:p>
+                      <a:pPr algn="ctr"/>
+                      <a:r>
+                        <a:rPr sz="850" b="1">
+                          <a:solidFill>
+                            <a:srgbClr val="000000"/>
+                          </a:solidFill>
+                        </a:rPr>
+                        <a:t>IDR 6.69T</a:t>
+                      </a:r>
+                    </a:p>
+                  </a:txBody>
+                  <a:tcPr>
+                    <a:solidFill>
+                      <a:srgbClr val="FFFFFF"/>
+                    </a:solidFill>
+                  </a:tcPr>
+                </a:tc>
+              </a:tr>
+              <a:tr h="283464">
+                <a:tc>
+                  <a:txBody>
+                    <a:bodyPr wrap="none"/>
+                    <a:lstStyle/>
+                    <a:p>
+                      <a:pPr algn="l"/>
+                      <a:r>
+                        <a:rPr sz="850" b="0">
+                          <a:solidFill>
+                            <a:srgbClr val="000000"/>
+                          </a:solidFill>
+                        </a:rPr>
+                        <a:t>% 2024 GDP</a:t>
+                      </a:r>
+                    </a:p>
+                  </a:txBody>
+                  <a:tcPr>
+                    <a:solidFill>
+                      <a:srgbClr val="F2F2F2"/>
+                    </a:solidFill>
+                  </a:tcPr>
+                </a:tc>
+                <a:tc>
+                  <a:txBody>
+                    <a:bodyPr wrap="none"/>
+                    <a:lstStyle/>
+                    <a:p>
+                      <a:pPr algn="ctr"/>
+                      <a:r>
+                        <a:rPr sz="850" b="0">
+                          <a:solidFill>
+                            <a:srgbClr val="000000"/>
+                          </a:solidFill>
+                        </a:rPr>
+                        <a:t>0.030%</a:t>
+                      </a:r>
+                    </a:p>
+                  </a:txBody>
+                  <a:tcPr>
+                    <a:solidFill>
+                      <a:srgbClr val="F2F2F2"/>
+                    </a:solidFill>
+                  </a:tcPr>
+                </a:tc>
+              </a:tr>
+              <a:tr h="283464">
+                <a:tc>
+                  <a:txBody>
+                    <a:bodyPr wrap="none"/>
+                    <a:lstStyle/>
+                    <a:p>
+                      <a:pPr algn="l"/>
+                      <a:r>
+                        <a:rPr sz="850" b="0">
+                          <a:solidFill>
+                            <a:srgbClr val="000000"/>
+                          </a:solidFill>
+                        </a:rPr>
+                        <a:t>% 2030 GDP (est.)</a:t>
+                      </a:r>
+                    </a:p>
+                  </a:txBody>
+                  <a:tcPr>
+                    <a:solidFill>
+                      <a:srgbClr val="FFFFFF"/>
+                    </a:solidFill>
+                  </a:tcPr>
+                </a:tc>
+                <a:tc>
+                  <a:txBody>
+                    <a:bodyPr wrap="none"/>
+                    <a:lstStyle/>
+                    <a:p>
+                      <a:pPr algn="ctr"/>
+                      <a:r>
+                        <a:rPr sz="850" b="0">
+                          <a:solidFill>
+                            <a:srgbClr val="000000"/>
+                          </a:solidFill>
+                        </a:rPr>
+                        <a:t>0.020%</a:t>
+                      </a:r>
+                    </a:p>
+                  </a:txBody>
+                  <a:tcPr>
+                    <a:solidFill>
+                      <a:srgbClr val="FFFFFF"/>
+                    </a:solidFill>
+                  </a:tcPr>
+                </a:tc>
+              </a:tr>
+              <a:tr h="283464">
+                <a:tc>
+                  <a:txBody>
+                    <a:bodyPr wrap="none"/>
+                    <a:lstStyle/>
+                    <a:p>
+                      <a:pPr algn="l"/>
+                      <a:r>
+                        <a:rPr sz="850" b="0">
+                          <a:solidFill>
+                            <a:srgbClr val="000000"/>
+                          </a:solidFill>
+                        </a:rPr>
+                        <a:t>Scenario B cumulative</a:t>
+                      </a:r>
+                    </a:p>
+                  </a:txBody>
+                  <a:tcPr>
+                    <a:solidFill>
+                      <a:srgbClr val="F2F2F2"/>
+                    </a:solidFill>
+                  </a:tcPr>
+                </a:tc>
+                <a:tc>
+                  <a:txBody>
+                    <a:bodyPr wrap="none"/>
+                    <a:lstStyle/>
+                    <a:p>
+                      <a:pPr algn="ctr"/>
+                      <a:r>
+                        <a:rPr sz="850" b="0">
+                          <a:solidFill>
+                            <a:srgbClr val="000000"/>
+                          </a:solidFill>
+                        </a:rPr>
+                        <a:t>IDR 77.1T</a:t>
+                      </a:r>
+                    </a:p>
+                  </a:txBody>
+                  <a:tcPr>
+                    <a:solidFill>
+                      <a:srgbClr val="F2F2F2"/>
+                    </a:solidFill>
+                  </a:tcPr>
+                </a:tc>
+              </a:tr>
+            </a:tbl>
+          </a:graphicData>
+        </a:graphic>
+      </p:graphicFrame>
+      <p:sp>
+        <p:nvSpPr>
+          <p:cNvPr id="9" name="TextBox 8"/>
+          <p:cNvSpPr txBox="1"/>
+          <p:nvPr/>
+        </p:nvSpPr>
+        <p:spPr>
+          <a:xfrm>
+            <a:off x="6309360" y="841248"/>
+            <a:ext cx="5577840" cy="228600"/>
+          </a:xfrm>
+          <a:prstGeom prst="rect">
+            <a:avLst/>
+          </a:prstGeom>
+          <a:noFill/>
+        </p:spPr>
+        <p:txBody>
+          <a:bodyPr wrap="square">
+            <a:spAutoFit/>
+          </a:bodyPr>
+          <a:lstStyle/>
+          <a:p>
+            <a:pPr algn="l"/>
+            <a:r>
+              <a:rPr sz="1000" b="1">
+                <a:solidFill>
+                  <a:srgbClr val="1B3A6B"/>
+                </a:solidFill>
+              </a:rPr>
+              <a:t>VAT / Import Duty (Universal Extension)</a:t>
+            </a:r>
+          </a:p>
+        </p:txBody>
+      </p:sp>
+      <p:sp>
+        <p:nvSpPr>
+          <p:cNvPr id="10" name="TextBox 9"/>
+          <p:cNvSpPr txBox="1"/>
+          <p:nvPr/>
+        </p:nvSpPr>
+        <p:spPr>
+          <a:xfrm>
+            <a:off x="6309360" y="1078992"/>
+            <a:ext cx="5577840" cy="256032"/>
+          </a:xfrm>
+          <a:prstGeom prst="rect">
+            <a:avLst/>
+          </a:prstGeom>
+          <a:noFill/>
+        </p:spPr>
+        <p:txBody>
+          <a:bodyPr wrap="square">
+            <a:spAutoFit/>
+          </a:bodyPr>
+          <a:lstStyle/>
+          <a:p>
+            <a:pPr algn="l"/>
+            <a:r>
+              <a:rPr sz="800" b="0">
+                <a:solidFill>
+                  <a:srgbClr val="000000"/>
+                </a:solidFill>
+              </a:rPr>
+              <a:t>Extend SEZ VAT (11%) + import duty waiver (2.5%) to all operators; 35% equipment share.</a:t>
+            </a:r>
+          </a:p>
+        </p:txBody>
+      </p:sp>
+      <p:graphicFrame>
+        <p:nvGraphicFramePr>
+          <p:cNvPr id="11" name="Table 10"/>
+          <p:cNvGraphicFramePr>
+            <a:graphicFrameLocks noGrp="1"/>
+          </p:cNvGraphicFramePr>
+          <p:nvPr/>
+        </p:nvGraphicFramePr>
+        <p:xfrm>
+          <a:off x="6309360" y="1371600"/>
+          <a:ext cx="5577840" cy="1417320"/>
+        </p:xfrm>
+        <a:graphic>
+          <a:graphicData uri="http://schemas.openxmlformats.org/drawingml/2006/table">
+            <a:tbl>
+              <a:tblPr firstRow="1" bandRow="1">
+                <a:tableStyleId>{5C22544A-7EE6-4342-B048-85BDC9FD1C3A}</a:tableStyleId>
+              </a:tblPr>
+              <a:tblGrid>
+                <a:gridCol w="2788920"/>
+                <a:gridCol w="1394460"/>
+                <a:gridCol w="1394460"/>
+              </a:tblGrid>
+              <a:tr h="283464">
+                <a:tc>
+                  <a:txBody>
+                    <a:bodyPr wrap="none"/>
+                    <a:lstStyle/>
+                    <a:p>
+                      <a:pPr algn="l"/>
+                      <a:r>
+                        <a:rPr sz="850" b="1">
+                          <a:solidFill>
+                            <a:srgbClr val="FFFFFF"/>
+                          </a:solidFill>
+                        </a:rPr>
+                        <a:t>Component</a:t>
+                      </a:r>
+                    </a:p>
+                  </a:txBody>
+                  <a:tcPr>
+                    <a:solidFill>
+                      <a:srgbClr val="1B3A6B"/>
+                    </a:solidFill>
+                  </a:tcPr>
+                </a:tc>
+                <a:tc>
+                  <a:txBody>
+                    <a:bodyPr wrap="none"/>
+                    <a:lstStyle/>
+                    <a:p>
+                      <a:pPr algn="ctr"/>
+                      <a:r>
+                        <a:rPr sz="850" b="1">
+                          <a:solidFill>
+                            <a:srgbClr val="FFFFFF"/>
+                          </a:solidFill>
+                        </a:rPr>
+                        <a:t>On A base</a:t>
+                      </a:r>
+                    </a:p>
+                  </a:txBody>
+                  <a:tcPr>
+                    <a:solidFill>
+                      <a:srgbClr val="1B3A6B"/>
+                    </a:solidFill>
+                  </a:tcPr>
+                </a:tc>
+                <a:tc>
+                  <a:txBody>
+                    <a:bodyPr wrap="none"/>
+                    <a:lstStyle/>
+                    <a:p>
+                      <a:pPr algn="ctr"/>
+                      <a:r>
+                        <a:rPr sz="850" b="1">
+                          <a:solidFill>
+                            <a:srgbClr val="FFFFFF"/>
+                          </a:solidFill>
+                        </a:rPr>
+                        <a:t>On B base</a:t>
+                      </a:r>
+                    </a:p>
+                  </a:txBody>
+                  <a:tcPr>
+                    <a:solidFill>
+                      <a:srgbClr val="1B3A6B"/>
+                    </a:solidFill>
+                  </a:tcPr>
+                </a:tc>
+              </a:tr>
+              <a:tr h="283464">
+                <a:tc>
+                  <a:txBody>
+                    <a:bodyPr wrap="none"/>
+                    <a:lstStyle/>
+                    <a:p>
+                      <a:pPr algn="l"/>
+                      <a:r>
+                        <a:rPr sz="850" b="0">
+                          <a:solidFill>
+                            <a:srgbClr val="000000"/>
+                          </a:solidFill>
+                        </a:rPr>
+                        <a:t>Equipment base (IDR T)</a:t>
+                      </a:r>
+                    </a:p>
+                  </a:txBody>
+                  <a:tcPr>
+                    <a:solidFill>
+                      <a:srgbClr val="FFFFFF"/>
+                    </a:solidFill>
+                  </a:tcPr>
+                </a:tc>
+                <a:tc>
+                  <a:txBody>
+                    <a:bodyPr wrap="none"/>
+                    <a:lstStyle/>
+                    <a:p>
+                      <a:pPr algn="ctr"/>
+                      <a:r>
+                        <a:rPr sz="850" b="0">
+                          <a:solidFill>
+                            <a:srgbClr val="000000"/>
+                          </a:solidFill>
+                        </a:rPr>
+                        <a:t>83.9</a:t>
+                      </a:r>
+                    </a:p>
+                  </a:txBody>
+                  <a:tcPr>
+                    <a:solidFill>
+                      <a:srgbClr val="FFFFFF"/>
+                    </a:solidFill>
+                  </a:tcPr>
+                </a:tc>
+                <a:tc>
+                  <a:txBody>
+                    <a:bodyPr wrap="none"/>
+                    <a:lstStyle/>
+                    <a:p>
+                      <a:pPr algn="ctr"/>
+                      <a:r>
+                        <a:rPr sz="850" b="0">
+                          <a:solidFill>
+                            <a:srgbClr val="000000"/>
+                          </a:solidFill>
+                        </a:rPr>
+                        <a:t>122.7</a:t>
+                      </a:r>
+                    </a:p>
+                  </a:txBody>
+                  <a:tcPr>
+                    <a:solidFill>
+                      <a:srgbClr val="FFFFFF"/>
+                    </a:solidFill>
+                  </a:tcPr>
+                </a:tc>
+              </a:tr>
+              <a:tr h="283464">
+                <a:tc>
+                  <a:txBody>
+                    <a:bodyPr wrap="none"/>
+                    <a:lstStyle/>
+                    <a:p>
+                      <a:pPr algn="l"/>
+                      <a:r>
+                        <a:rPr sz="850" b="0">
+                          <a:solidFill>
+                            <a:srgbClr val="000000"/>
+                          </a:solidFill>
+                        </a:rPr>
+                        <a:t>VAT (11%)</a:t>
+                      </a:r>
+                    </a:p>
+                  </a:txBody>
+                  <a:tcPr>
+                    <a:solidFill>
+                      <a:srgbClr val="F2F2F2"/>
+                    </a:solidFill>
+                  </a:tcPr>
+                </a:tc>
+                <a:tc>
+                  <a:txBody>
+                    <a:bodyPr wrap="none"/>
+                    <a:lstStyle/>
+                    <a:p>
+                      <a:pPr algn="ctr"/>
+                      <a:r>
+                        <a:rPr sz="850" b="0">
+                          <a:solidFill>
+                            <a:srgbClr val="000000"/>
+                          </a:solidFill>
+                        </a:rPr>
+                        <a:t>9.2</a:t>
+                      </a:r>
+                    </a:p>
+                  </a:txBody>
+                  <a:tcPr>
+                    <a:solidFill>
+                      <a:srgbClr val="F2F2F2"/>
+                    </a:solidFill>
+                  </a:tcPr>
+                </a:tc>
+                <a:tc>
+                  <a:txBody>
+                    <a:bodyPr wrap="none"/>
+                    <a:lstStyle/>
+                    <a:p>
+                      <a:pPr algn="ctr"/>
+                      <a:r>
+                        <a:rPr sz="850" b="0">
+                          <a:solidFill>
+                            <a:srgbClr val="000000"/>
+                          </a:solidFill>
+                        </a:rPr>
+                        <a:t>13.5</a:t>
+                      </a:r>
+                    </a:p>
+                  </a:txBody>
+                  <a:tcPr>
+                    <a:solidFill>
+                      <a:srgbClr val="F2F2F2"/>
+                    </a:solidFill>
+                  </a:tcPr>
+                </a:tc>
+              </a:tr>
+              <a:tr h="283464">
+                <a:tc>
+                  <a:txBody>
+                    <a:bodyPr wrap="none"/>
+                    <a:lstStyle/>
+                    <a:p>
+                      <a:pPr algn="l"/>
+                      <a:r>
+                        <a:rPr sz="850" b="0">
+                          <a:solidFill>
+                            <a:srgbClr val="000000"/>
+                          </a:solidFill>
+                        </a:rPr>
+                        <a:t>Import duty (2.5%)</a:t>
+                      </a:r>
+                    </a:p>
+                  </a:txBody>
+                  <a:tcPr>
+                    <a:solidFill>
+                      <a:srgbClr val="FFFFFF"/>
+                    </a:solidFill>
+                  </a:tcPr>
+                </a:tc>
+                <a:tc>
+                  <a:txBody>
+                    <a:bodyPr wrap="none"/>
+                    <a:lstStyle/>
+                    <a:p>
+                      <a:pPr algn="ctr"/>
+                      <a:r>
+                        <a:rPr sz="850" b="0">
+                          <a:solidFill>
+                            <a:srgbClr val="000000"/>
+                          </a:solidFill>
+                        </a:rPr>
+                        <a:t>2.0</a:t>
+                      </a:r>
+                    </a:p>
+                  </a:txBody>
+                  <a:tcPr>
+                    <a:solidFill>
+                      <a:srgbClr val="FFFFFF"/>
+                    </a:solidFill>
+                  </a:tcPr>
+                </a:tc>
+                <a:tc>
+                  <a:txBody>
+                    <a:bodyPr wrap="none"/>
+                    <a:lstStyle/>
+                    <a:p>
+                      <a:pPr algn="ctr"/>
+                      <a:r>
+                        <a:rPr sz="850" b="0">
+                          <a:solidFill>
+                            <a:srgbClr val="000000"/>
+                          </a:solidFill>
+                        </a:rPr>
+                        <a:t>2.9</a:t>
+                      </a:r>
+                    </a:p>
+                  </a:txBody>
+                  <a:tcPr>
+                    <a:solidFill>
+                      <a:srgbClr val="FFFFFF"/>
+                    </a:solidFill>
+                  </a:tcPr>
+                </a:tc>
+              </a:tr>
+              <a:tr h="283464">
+                <a:tc>
+                  <a:txBody>
+                    <a:bodyPr wrap="none"/>
+                    <a:lstStyle/>
+                    <a:p>
+                      <a:pPr algn="l"/>
+                      <a:r>
+                        <a:rPr sz="850" b="1">
+                          <a:solidFill>
+                            <a:srgbClr val="FFFFFF"/>
+                          </a:solidFill>
+                        </a:rPr>
+                        <a:t>VAT+Duty total</a:t>
+                      </a:r>
+                    </a:p>
+                  </a:txBody>
+                  <a:tcPr>
+                    <a:solidFill>
+                      <a:srgbClr val="1B3A6B"/>
+                    </a:solidFill>
+                  </a:tcPr>
+                </a:tc>
+                <a:tc>
+                  <a:txBody>
+                    <a:bodyPr wrap="none"/>
+                    <a:lstStyle/>
+                    <a:p>
+                      <a:pPr algn="ctr"/>
+                      <a:r>
+                        <a:rPr sz="850" b="1">
+                          <a:solidFill>
+                            <a:srgbClr val="FFFFFF"/>
+                          </a:solidFill>
+                        </a:rPr>
+                        <a:t>11.2</a:t>
+                      </a:r>
+                    </a:p>
+                  </a:txBody>
+                  <a:tcPr>
+                    <a:solidFill>
+                      <a:srgbClr val="1B3A6B"/>
+                    </a:solidFill>
+                  </a:tcPr>
+                </a:tc>
+                <a:tc>
+                  <a:txBody>
+                    <a:bodyPr wrap="none"/>
+                    <a:lstStyle/>
+                    <a:p>
+                      <a:pPr algn="ctr"/>
+                      <a:r>
+                        <a:rPr sz="850" b="1">
+                          <a:solidFill>
+                            <a:srgbClr val="FFFFFF"/>
+                          </a:solidFill>
+                        </a:rPr>
+                        <a:t>16.4</a:t>
+                      </a:r>
+                    </a:p>
+                  </a:txBody>
+                  <a:tcPr>
+                    <a:solidFill>
+                      <a:srgbClr val="1B3A6B"/>
+                    </a:solidFill>
+                  </a:tcPr>
+                </a:tc>
+              </a:tr>
+            </a:tbl>
+          </a:graphicData>
+        </a:graphic>
+      </p:graphicFrame>
+      <p:sp>
+        <p:nvSpPr>
+          <p:cNvPr id="12" name="TextBox 11"/>
+          <p:cNvSpPr txBox="1"/>
+          <p:nvPr/>
+        </p:nvSpPr>
+        <p:spPr>
+          <a:xfrm>
+            <a:off x="6309360" y="2944368"/>
+            <a:ext cx="5577840" cy="228600"/>
+          </a:xfrm>
+          <a:prstGeom prst="rect">
+            <a:avLst/>
+          </a:prstGeom>
+          <a:noFill/>
+        </p:spPr>
+        <p:txBody>
+          <a:bodyPr wrap="square">
+            <a:spAutoFit/>
+          </a:bodyPr>
+          <a:lstStyle/>
+          <a:p>
+            <a:pPr algn="l"/>
+            <a:r>
+              <a:rPr sz="1000" b="1">
+                <a:solidFill>
+                  <a:srgbClr val="1B3A6B"/>
+                </a:solidFill>
+              </a:rPr>
+              <a:t>Combined Summary</a:t>
+            </a:r>
+          </a:p>
+        </p:txBody>
+      </p:sp>
+      <p:graphicFrame>
+        <p:nvGraphicFramePr>
+          <p:cNvPr id="13" name="Table 12"/>
+          <p:cNvGraphicFramePr>
+            <a:graphicFrameLocks noGrp="1"/>
+          </p:cNvGraphicFramePr>
+          <p:nvPr/>
+        </p:nvGraphicFramePr>
+        <p:xfrm>
+          <a:off x="6309360" y="3200400"/>
+          <a:ext cx="5577838" cy="1828800"/>
+        </p:xfrm>
+        <a:graphic>
+          <a:graphicData uri="http://schemas.openxmlformats.org/drawingml/2006/table">
+            <a:tbl>
+              <a:tblPr firstRow="1" bandRow="1">
+                <a:tableStyleId>{5C22544A-7EE6-4342-B048-85BDC9FD1C3A}</a:tableStyleId>
+              </a:tblPr>
+              <a:tblGrid>
+                <a:gridCol w="2900476"/>
+                <a:gridCol w="1338681"/>
+                <a:gridCol w="1338681"/>
+              </a:tblGrid>
+              <a:tr h="304800">
+                <a:tc>
+                  <a:txBody>
+                    <a:bodyPr wrap="none"/>
+                    <a:lstStyle/>
+                    <a:p>
+                      <a:pPr algn="l"/>
+                      <a:r>
+                        <a:rPr sz="850" b="1">
+                          <a:solidFill>
+                            <a:srgbClr val="FFFFFF"/>
+                          </a:solidFill>
+                        </a:rPr>
+                        <a:t>Scenario</a:t>
+                      </a:r>
+                    </a:p>
+                  </a:txBody>
+                  <a:tcPr>
+                    <a:solidFill>
+                      <a:srgbClr val="1B3A6B"/>
+                    </a:solidFill>
+                  </a:tcPr>
+                </a:tc>
+                <a:tc>
+                  <a:txBody>
+                    <a:bodyPr wrap="none"/>
+                    <a:lstStyle/>
+                    <a:p>
+                      <a:pPr algn="ctr"/>
+                      <a:r>
+                        <a:rPr sz="850" b="1">
+                          <a:solidFill>
+                            <a:srgbClr val="FFFFFF"/>
+                          </a:solidFill>
+                        </a:rPr>
+                        <a:t>Ann. (IDR T)</a:t>
+                      </a:r>
+                    </a:p>
+                  </a:txBody>
+                  <a:tcPr>
+                    <a:solidFill>
+                      <a:srgbClr val="1B3A6B"/>
+                    </a:solidFill>
+                  </a:tcPr>
+                </a:tc>
+                <a:tc>
+                  <a:txBody>
+                    <a:bodyPr wrap="none"/>
+                    <a:lstStyle/>
+                    <a:p>
+                      <a:pPr algn="ctr"/>
+                      <a:r>
+                        <a:rPr sz="850" b="1">
+                          <a:solidFill>
+                            <a:srgbClr val="FFFFFF"/>
+                          </a:solidFill>
+                        </a:rPr>
+                        <a:t>Cum. (IDR T)</a:t>
+                      </a:r>
+                    </a:p>
+                  </a:txBody>
+                  <a:tcPr>
+                    <a:solidFill>
+                      <a:srgbClr val="1B3A6B"/>
+                    </a:solidFill>
+                  </a:tcPr>
+                </a:tc>
+              </a:tr>
+              <a:tr h="304800">
+                <a:tc>
+                  <a:txBody>
+                    <a:bodyPr wrap="none"/>
+                    <a:lstStyle/>
+                    <a:p>
+                      <a:pPr algn="l"/>
+                      <a:r>
+                        <a:rPr sz="850" b="0">
+                          <a:solidFill>
+                            <a:srgbClr val="000000"/>
+                          </a:solidFill>
+                        </a:rPr>
+                        <a:t>Baseline (526 MW)</a:t>
+                      </a:r>
+                    </a:p>
+                  </a:txBody>
+                  <a:tcPr>
+                    <a:solidFill>
+                      <a:srgbClr val="FFFFFF"/>
+                    </a:solidFill>
+                  </a:tcPr>
+                </a:tc>
+                <a:tc>
+                  <a:txBody>
+                    <a:bodyPr wrap="none"/>
+                    <a:lstStyle/>
+                    <a:p>
+                      <a:pPr algn="ctr"/>
+                      <a:r>
+                        <a:rPr sz="850" b="0">
+                          <a:solidFill>
+                            <a:srgbClr val="000000"/>
+                          </a:solidFill>
+                        </a:rPr>
+                        <a:t>1.57</a:t>
+                      </a:r>
+                    </a:p>
+                  </a:txBody>
+                  <a:tcPr>
+                    <a:solidFill>
+                      <a:srgbClr val="FFFFFF"/>
+                    </a:solidFill>
+                  </a:tcPr>
+                </a:tc>
+                <a:tc>
+                  <a:txBody>
+                    <a:bodyPr wrap="none"/>
+                    <a:lstStyle/>
+                    <a:p>
+                      <a:pPr algn="ctr"/>
+                      <a:r>
+                        <a:rPr sz="850" b="0">
+                          <a:solidFill>
+                            <a:srgbClr val="000000"/>
+                          </a:solidFill>
+                        </a:rPr>
+                        <a:t>18.1</a:t>
+                      </a:r>
+                    </a:p>
+                  </a:txBody>
+                  <a:tcPr>
+                    <a:solidFill>
+                      <a:srgbClr val="FFFFFF"/>
+                    </a:solidFill>
+                  </a:tcPr>
+                </a:tc>
+              </a:tr>
+              <a:tr h="304800">
+                <a:tc>
+                  <a:txBody>
+                    <a:bodyPr wrap="none"/>
+                    <a:lstStyle/>
+                    <a:p>
+                      <a:pPr algn="l"/>
+                      <a:r>
+                        <a:rPr sz="850" b="0">
+                          <a:solidFill>
+                            <a:srgbClr val="000000"/>
+                          </a:solidFill>
+                        </a:rPr>
+                        <a:t>Scenario A (2,000 MW)</a:t>
+                      </a:r>
+                    </a:p>
+                  </a:txBody>
+                  <a:tcPr>
+                    <a:solidFill>
+                      <a:srgbClr val="F2F2F2"/>
+                    </a:solidFill>
+                  </a:tcPr>
+                </a:tc>
+                <a:tc>
+                  <a:txBody>
+                    <a:bodyPr wrap="none"/>
+                    <a:lstStyle/>
+                    <a:p>
+                      <a:pPr algn="ctr"/>
+                      <a:r>
+                        <a:rPr sz="850" b="0">
+                          <a:solidFill>
+                            <a:srgbClr val="000000"/>
+                          </a:solidFill>
+                        </a:rPr>
+                        <a:t>4.62</a:t>
+                      </a:r>
+                    </a:p>
+                  </a:txBody>
+                  <a:tcPr>
+                    <a:solidFill>
+                      <a:srgbClr val="F2F2F2"/>
+                    </a:solidFill>
+                  </a:tcPr>
+                </a:tc>
+                <a:tc>
+                  <a:txBody>
+                    <a:bodyPr wrap="none"/>
+                    <a:lstStyle/>
+                    <a:p>
+                      <a:pPr algn="ctr"/>
+                      <a:r>
+                        <a:rPr sz="850" b="0">
+                          <a:solidFill>
+                            <a:srgbClr val="000000"/>
+                          </a:solidFill>
+                        </a:rPr>
+                        <a:t>53.2</a:t>
+                      </a:r>
+                    </a:p>
+                  </a:txBody>
+                  <a:tcPr>
+                    <a:solidFill>
+                      <a:srgbClr val="F2F2F2"/>
+                    </a:solidFill>
+                  </a:tcPr>
+                </a:tc>
+              </a:tr>
+              <a:tr h="304800">
+                <a:tc>
+                  <a:txBody>
+                    <a:bodyPr wrap="none"/>
+                    <a:lstStyle/>
+                    <a:p>
+                      <a:pPr algn="l"/>
+                      <a:r>
+                        <a:rPr sz="850" b="0">
+                          <a:solidFill>
+                            <a:srgbClr val="000000"/>
+                          </a:solidFill>
+                        </a:rPr>
+                        <a:t>Scenario B (3,000 MW)</a:t>
+                      </a:r>
+                    </a:p>
+                  </a:txBody>
+                  <a:tcPr>
+                    <a:solidFill>
+                      <a:srgbClr val="FFFFFF"/>
+                    </a:solidFill>
+                  </a:tcPr>
+                </a:tc>
+                <a:tc>
+                  <a:txBody>
+                    <a:bodyPr wrap="none"/>
+                    <a:lstStyle/>
+                    <a:p>
+                      <a:pPr algn="ctr"/>
+                      <a:r>
+                        <a:rPr sz="850" b="0">
+                          <a:solidFill>
+                            <a:srgbClr val="000000"/>
+                          </a:solidFill>
+                        </a:rPr>
+                        <a:t>6.69</a:t>
+                      </a:r>
+                    </a:p>
+                  </a:txBody>
+                  <a:tcPr>
+                    <a:solidFill>
+                      <a:srgbClr val="FFFFFF"/>
+                    </a:solidFill>
+                  </a:tcPr>
+                </a:tc>
+                <a:tc>
+                  <a:txBody>
+                    <a:bodyPr wrap="none"/>
+                    <a:lstStyle/>
+                    <a:p>
+                      <a:pPr algn="ctr"/>
+                      <a:r>
+                        <a:rPr sz="850" b="0">
+                          <a:solidFill>
+                            <a:srgbClr val="000000"/>
+                          </a:solidFill>
+                        </a:rPr>
+                        <a:t>77.1</a:t>
+                      </a:r>
+                    </a:p>
+                  </a:txBody>
+                  <a:tcPr>
+                    <a:solidFill>
+                      <a:srgbClr val="FFFFFF"/>
+                    </a:solidFill>
+                  </a:tcPr>
+                </a:tc>
+              </a:tr>
+              <a:tr h="304800">
+                <a:tc>
+                  <a:txBody>
+                    <a:bodyPr wrap="none"/>
+                    <a:lstStyle/>
+                    <a:p>
+                      <a:pPr algn="l"/>
+                      <a:r>
+                        <a:rPr sz="850" b="0">
+                          <a:solidFill>
+                            <a:srgbClr val="000000"/>
+                          </a:solidFill>
+                        </a:rPr>
+                        <a:t>Combined A + VAT</a:t>
+                      </a:r>
+                    </a:p>
+                  </a:txBody>
+                  <a:tcPr>
+                    <a:solidFill>
+                      <a:srgbClr val="F2F2F2"/>
+                    </a:solidFill>
+                  </a:tcPr>
+                </a:tc>
+                <a:tc>
+                  <a:txBody>
+                    <a:bodyPr wrap="none"/>
+                    <a:lstStyle/>
+                    <a:p>
+                      <a:pPr algn="ctr"/>
+                      <a:r>
+                        <a:rPr sz="850" b="0">
+                          <a:solidFill>
+                            <a:srgbClr val="000000"/>
+                          </a:solidFill>
+                        </a:rPr>
+                        <a:t>8.40</a:t>
+                      </a:r>
+                    </a:p>
+                  </a:txBody>
+                  <a:tcPr>
+                    <a:solidFill>
+                      <a:srgbClr val="F2F2F2"/>
+                    </a:solidFill>
+                  </a:tcPr>
+                </a:tc>
+                <a:tc>
+                  <a:txBody>
+                    <a:bodyPr wrap="none"/>
+                    <a:lstStyle/>
+                    <a:p>
+                      <a:pPr algn="ctr"/>
+                      <a:r>
+                        <a:rPr sz="850" b="0">
+                          <a:solidFill>
+                            <a:srgbClr val="000000"/>
+                          </a:solidFill>
+                        </a:rPr>
+                        <a:t>64.2</a:t>
+                      </a:r>
+                    </a:p>
+                  </a:txBody>
+                  <a:tcPr>
+                    <a:solidFill>
+                      <a:srgbClr val="F2F2F2"/>
+                    </a:solidFill>
+                  </a:tcPr>
+                </a:tc>
+              </a:tr>
+              <a:tr h="304800">
+                <a:tc>
+                  <a:txBody>
+                    <a:bodyPr wrap="none"/>
+                    <a:lstStyle/>
+                    <a:p>
+                      <a:pPr algn="l"/>
+                      <a:r>
+                        <a:rPr sz="850" b="1">
+                          <a:solidFill>
+                            <a:srgbClr val="FFFFFF"/>
+                          </a:solidFill>
+                        </a:rPr>
+                        <a:t>Combined B + VAT</a:t>
+                      </a:r>
+                    </a:p>
+                  </a:txBody>
+                  <a:tcPr>
+                    <a:solidFill>
+                      <a:srgbClr val="1B3A6B"/>
+                    </a:solidFill>
+                  </a:tcPr>
+                </a:tc>
+                <a:tc>
+                  <a:txBody>
+                    <a:bodyPr wrap="none"/>
+                    <a:lstStyle/>
+                    <a:p>
+                      <a:pPr algn="ctr"/>
+                      <a:r>
+                        <a:rPr sz="850" b="1">
+                          <a:solidFill>
+                            <a:srgbClr val="FFFFFF"/>
+                          </a:solidFill>
+                        </a:rPr>
+                        <a:t>12.22</a:t>
+                      </a:r>
+                    </a:p>
+                  </a:txBody>
+                  <a:tcPr>
+                    <a:solidFill>
+                      <a:srgbClr val="1B3A6B"/>
+                    </a:solidFill>
+                  </a:tcPr>
+                </a:tc>
+                <a:tc>
+                  <a:txBody>
+                    <a:bodyPr wrap="none"/>
+                    <a:lstStyle/>
+                    <a:p>
+                      <a:pPr algn="ctr"/>
+                      <a:r>
+                        <a:rPr sz="850" b="1">
+                          <a:solidFill>
+                            <a:srgbClr val="FFFFFF"/>
+                          </a:solidFill>
+                        </a:rPr>
+                        <a:t>93.3</a:t>
+                      </a:r>
+                    </a:p>
+                  </a:txBody>
+                  <a:tcPr>
+                    <a:solidFill>
+                      <a:srgbClr val="1B3A6B"/>
+                    </a:solidFill>
+                  </a:tcPr>
+                </a:tc>
+              </a:tr>
+            </a:tbl>
+          </a:graphicData>
+        </a:graphic>
+      </p:graphicFrame>
+      <p:sp>
+        <p:nvSpPr>
+          <p:cNvPr id="14" name="TextBox 13"/>
+          <p:cNvSpPr txBox="1"/>
+          <p:nvPr/>
+        </p:nvSpPr>
+        <p:spPr>
+          <a:xfrm>
+            <a:off x="6309360" y="5102352"/>
+            <a:ext cx="5577840" cy="256032"/>
+          </a:xfrm>
+          <a:prstGeom prst="rect">
+            <a:avLst/>
+          </a:prstGeom>
+          <a:noFill/>
+        </p:spPr>
+        <p:txBody>
+          <a:bodyPr wrap="square">
+            <a:spAutoFit/>
+          </a:bodyPr>
+          <a:lstStyle/>
+          <a:p>
+            <a:pPr algn="l"/>
+            <a:r>
+              <a:rPr sz="750" b="0">
+                <a:solidFill>
+                  <a:srgbClr val="CCCCCC"/>
+                </a:solidFill>
+              </a:rPr>
+              <a:t>Annual = peak CIT/yr + VAT÷3 yr. % 2030 GDP based on IDR 34,167T estimate.</a:t>
+            </a:r>
+          </a:p>
+        </p:txBody>
+      </p:sp>
+    </p:spTree>
+  </p:cSld>
+  <p:clrMapOvr>
+    <a:masterClrMapping/>
+  </p:clrMapOvr>
+</p:sld>
+</file>
+
+<file path=ppt/slides/slide5.xml><?xml version="1.0" encoding="utf-8"?>
 <p:sld xmlns:a="http://schemas.openxmlformats.org/drawingml/2006/main" xmlns:p="http://schemas.openxmlformats.org/presentationml/2006/main" xmlns:r="http://schemas.openxmlformats.org/officeDocument/2006/relationships">
   <p:cSld>
     <p:spTree>

</xml_diff>